<commit_message>
Add 'on the page' mockup slide after each concept animation
After a concept's animation, a second slide now shows a fixed wireframe
of the chat app with ONE region ringed, so students see where that piece
actually lives - the <header> strip, the Send button, the user bubble
margin-left pushes right, the log overflow-y scrolls.

- build.py: concept_mockup() draws the wireframe as inline SVG (pulsing
  highlight ring) for the HTML deck; mockup_slide() draws the same with
  python-pptx shapes for the .pptx. slide_plan emits a "mockup" descriptor
  after any concept with a placement, so both decks add it and stay in
  count-sync (812 slides).
- course.py: PLACEMENTS maps ~60 concepts to a region + caption. Pure
  behind-the-scenes logic gets no mockup.
- SLIDE-RULES.md: documents the placement slide.

Co-Authored-By: Claude Opus 4.8 <noreply@anthropic.com>
</commit_message>
<xml_diff>
--- a/ai101/slides/week-05.pptx
+++ b/ai101/slides/week-05.pptx
@@ -50,6 +50,7 @@
     <p:sldId id="298" r:id="rId49"/>
     <p:sldId id="299" r:id="rId50"/>
     <p:sldId id="300" r:id="rId51"/>
+    <p:sldId id="301" r:id="rId52"/>
   </p:sldIdLst>
   <p:sldSz cx="12191695" cy="6858000" type="screen4x3"/>
   <p:notesSz cx="6858000" cy="9144000"/>
@@ -16403,6 +16404,615 @@
     <p:bg>
       <p:bgPr>
         <a:solidFill>
+          <a:srgbClr val="F4F8FB"/>
+        </a:solidFill>
+        <a:effectLst/>
+      </p:bgPr>
+    </p:bg>
+    <p:spTree>
+      <p:nvGrpSpPr>
+        <p:cNvPr id="1" name=""/>
+        <p:cNvGrpSpPr/>
+        <p:nvPr/>
+      </p:nvGrpSpPr>
+      <p:grpSpPr/>
+      <p:sp>
+        <p:nvSpPr>
+          <p:cNvPr id="2" name="TextBox 1"/>
+          <p:cNvSpPr txBox="1"/>
+          <p:nvPr/>
+        </p:nvSpPr>
+        <p:spPr>
+          <a:xfrm>
+            <a:off x="822960" y="365760"/>
+            <a:ext cx="7315200" cy="365760"/>
+          </a:xfrm>
+          <a:prstGeom prst="rect">
+            <a:avLst/>
+          </a:prstGeom>
+          <a:noFill/>
+        </p:spPr>
+        <p:txBody>
+          <a:bodyPr wrap="none">
+            <a:spAutoFit/>
+          </a:bodyPr>
+          <a:lstStyle/>
+          <a:p>
+            <a:r>
+              <a:rPr sz="1400" b="1">
+                <a:solidFill>
+                  <a:srgbClr val="01AEFD"/>
+                </a:solidFill>
+              </a:rPr>
+              <a:t>ON THE PAGE</a:t>
+            </a:r>
+          </a:p>
+        </p:txBody>
+      </p:sp>
+      <p:sp>
+        <p:nvSpPr>
+          <p:cNvPr id="3" name="TextBox 2"/>
+          <p:cNvSpPr txBox="1"/>
+          <p:nvPr/>
+        </p:nvSpPr>
+        <p:spPr>
+          <a:xfrm>
+            <a:off x="822960" y="658368"/>
+            <a:ext cx="10515600" cy="731520"/>
+          </a:xfrm>
+          <a:prstGeom prst="rect">
+            <a:avLst/>
+          </a:prstGeom>
+          <a:noFill/>
+        </p:spPr>
+        <p:txBody>
+          <a:bodyPr wrap="none">
+            <a:spAutoFit/>
+          </a:bodyPr>
+          <a:lstStyle/>
+          <a:p>
+            <a:r>
+              <a:rPr sz="3200" b="1">
+                <a:solidFill>
+                  <a:srgbClr val="1F2A37"/>
+                </a:solidFill>
+              </a:rPr>
+              <a:t>line-height</a:t>
+            </a:r>
+          </a:p>
+        </p:txBody>
+      </p:sp>
+      <p:sp>
+        <p:nvSpPr>
+          <p:cNvPr id="4" name="Rounded Rectangle 3"/>
+          <p:cNvSpPr/>
+          <p:nvPr/>
+        </p:nvSpPr>
+        <p:spPr>
+          <a:xfrm>
+            <a:off x="3454237" y="1641896"/>
+            <a:ext cx="5249387" cy="3918021"/>
+          </a:xfrm>
+          <a:prstGeom prst="roundRect">
+            <a:avLst/>
+          </a:prstGeom>
+          <a:solidFill>
+            <a:srgbClr val="0F1F27"/>
+          </a:solidFill>
+          <a:ln>
+            <a:noFill/>
+          </a:ln>
+          <a:effectLst/>
+        </p:spPr>
+        <p:style>
+          <a:lnRef idx="1">
+            <a:schemeClr val="accent1"/>
+          </a:lnRef>
+          <a:fillRef idx="3">
+            <a:schemeClr val="accent1"/>
+          </a:fillRef>
+          <a:effectRef idx="2">
+            <a:schemeClr val="accent1"/>
+          </a:effectRef>
+          <a:fontRef idx="minor">
+            <a:schemeClr val="lt1"/>
+          </a:fontRef>
+        </p:style>
+        <p:txBody>
+          <a:bodyPr rtlCol="0" anchor="ctr"/>
+          <a:lstStyle/>
+          <a:p>
+            <a:pPr algn="ctr"/>
+          </a:p>
+        </p:txBody>
+      </p:sp>
+      <p:sp>
+        <p:nvSpPr>
+          <p:cNvPr id="5" name="Rounded Rectangle 4"/>
+          <p:cNvSpPr/>
+          <p:nvPr/>
+        </p:nvSpPr>
+        <p:spPr>
+          <a:xfrm>
+            <a:off x="3606393" y="2022287"/>
+            <a:ext cx="4945075" cy="437448"/>
+          </a:xfrm>
+          <a:prstGeom prst="roundRect">
+            <a:avLst/>
+          </a:prstGeom>
+          <a:solidFill>
+            <a:srgbClr val="16303A"/>
+          </a:solidFill>
+          <a:ln>
+            <a:noFill/>
+          </a:ln>
+          <a:effectLst/>
+        </p:spPr>
+        <p:style>
+          <a:lnRef idx="1">
+            <a:schemeClr val="accent1"/>
+          </a:lnRef>
+          <a:fillRef idx="3">
+            <a:schemeClr val="accent1"/>
+          </a:fillRef>
+          <a:effectRef idx="2">
+            <a:schemeClr val="accent1"/>
+          </a:effectRef>
+          <a:fontRef idx="minor">
+            <a:schemeClr val="lt1"/>
+          </a:fontRef>
+        </p:style>
+        <p:txBody>
+          <a:bodyPr rtlCol="0" anchor="ctr"/>
+          <a:lstStyle/>
+          <a:p>
+            <a:pPr algn="ctr"/>
+          </a:p>
+        </p:txBody>
+      </p:sp>
+      <p:sp>
+        <p:nvSpPr>
+          <p:cNvPr id="6" name="Rounded Rectangle 5"/>
+          <p:cNvSpPr/>
+          <p:nvPr/>
+        </p:nvSpPr>
+        <p:spPr>
+          <a:xfrm>
+            <a:off x="3720510" y="2155423"/>
+            <a:ext cx="1426463" cy="190195"/>
+          </a:xfrm>
+          <a:prstGeom prst="roundRect">
+            <a:avLst/>
+          </a:prstGeom>
+          <a:solidFill>
+            <a:srgbClr val="4A6B78"/>
+          </a:solidFill>
+          <a:ln>
+            <a:noFill/>
+          </a:ln>
+          <a:effectLst/>
+        </p:spPr>
+        <p:style>
+          <a:lnRef idx="1">
+            <a:schemeClr val="accent1"/>
+          </a:lnRef>
+          <a:fillRef idx="3">
+            <a:schemeClr val="accent1"/>
+          </a:fillRef>
+          <a:effectRef idx="2">
+            <a:schemeClr val="accent1"/>
+          </a:effectRef>
+          <a:fontRef idx="minor">
+            <a:schemeClr val="lt1"/>
+          </a:fontRef>
+        </p:style>
+        <p:txBody>
+          <a:bodyPr rtlCol="0" anchor="ctr"/>
+          <a:lstStyle/>
+          <a:p>
+            <a:pPr algn="ctr"/>
+          </a:p>
+        </p:txBody>
+      </p:sp>
+      <p:sp>
+        <p:nvSpPr>
+          <p:cNvPr id="7" name="Rounded Rectangle 6"/>
+          <p:cNvSpPr/>
+          <p:nvPr/>
+        </p:nvSpPr>
+        <p:spPr>
+          <a:xfrm>
+            <a:off x="3606393" y="2554833"/>
+            <a:ext cx="4945075" cy="1806854"/>
+          </a:xfrm>
+          <a:prstGeom prst="roundRect">
+            <a:avLst/>
+          </a:prstGeom>
+          <a:solidFill>
+            <a:srgbClr val="0B171D"/>
+          </a:solidFill>
+          <a:ln>
+            <a:noFill/>
+          </a:ln>
+          <a:effectLst/>
+        </p:spPr>
+        <p:style>
+          <a:lnRef idx="1">
+            <a:schemeClr val="accent1"/>
+          </a:lnRef>
+          <a:fillRef idx="3">
+            <a:schemeClr val="accent1"/>
+          </a:fillRef>
+          <a:effectRef idx="2">
+            <a:schemeClr val="accent1"/>
+          </a:effectRef>
+          <a:fontRef idx="minor">
+            <a:schemeClr val="lt1"/>
+          </a:fontRef>
+        </p:style>
+        <p:txBody>
+          <a:bodyPr rtlCol="0" anchor="ctr"/>
+          <a:lstStyle/>
+          <a:p>
+            <a:pPr algn="ctr"/>
+          </a:p>
+        </p:txBody>
+      </p:sp>
+      <p:sp>
+        <p:nvSpPr>
+          <p:cNvPr id="8" name="Rounded Rectangle 7"/>
+          <p:cNvSpPr/>
+          <p:nvPr/>
+        </p:nvSpPr>
+        <p:spPr>
+          <a:xfrm>
+            <a:off x="3720510" y="2668950"/>
+            <a:ext cx="2852927" cy="399409"/>
+          </a:xfrm>
+          <a:prstGeom prst="roundRect">
+            <a:avLst/>
+          </a:prstGeom>
+          <a:solidFill>
+            <a:srgbClr val="1B3540"/>
+          </a:solidFill>
+          <a:ln>
+            <a:noFill/>
+          </a:ln>
+          <a:effectLst/>
+        </p:spPr>
+        <p:style>
+          <a:lnRef idx="1">
+            <a:schemeClr val="accent1"/>
+          </a:lnRef>
+          <a:fillRef idx="3">
+            <a:schemeClr val="accent1"/>
+          </a:fillRef>
+          <a:effectRef idx="2">
+            <a:schemeClr val="accent1"/>
+          </a:effectRef>
+          <a:fontRef idx="minor">
+            <a:schemeClr val="lt1"/>
+          </a:fontRef>
+        </p:style>
+        <p:txBody>
+          <a:bodyPr rtlCol="0" anchor="ctr"/>
+          <a:lstStyle/>
+          <a:p>
+            <a:pPr algn="ctr"/>
+          </a:p>
+        </p:txBody>
+      </p:sp>
+      <p:sp>
+        <p:nvSpPr>
+          <p:cNvPr id="9" name="Rounded Rectangle 8"/>
+          <p:cNvSpPr/>
+          <p:nvPr/>
+        </p:nvSpPr>
+        <p:spPr>
+          <a:xfrm>
+            <a:off x="5584423" y="3182477"/>
+            <a:ext cx="2852927" cy="399409"/>
+          </a:xfrm>
+          <a:prstGeom prst="roundRect">
+            <a:avLst/>
+          </a:prstGeom>
+          <a:solidFill>
+            <a:srgbClr val="123A32"/>
+          </a:solidFill>
+          <a:ln>
+            <a:noFill/>
+          </a:ln>
+          <a:effectLst/>
+        </p:spPr>
+        <p:style>
+          <a:lnRef idx="1">
+            <a:schemeClr val="accent1"/>
+          </a:lnRef>
+          <a:fillRef idx="3">
+            <a:schemeClr val="accent1"/>
+          </a:fillRef>
+          <a:effectRef idx="2">
+            <a:schemeClr val="accent1"/>
+          </a:effectRef>
+          <a:fontRef idx="minor">
+            <a:schemeClr val="lt1"/>
+          </a:fontRef>
+        </p:style>
+        <p:txBody>
+          <a:bodyPr rtlCol="0" anchor="ctr"/>
+          <a:lstStyle/>
+          <a:p>
+            <a:pPr algn="ctr"/>
+          </a:p>
+        </p:txBody>
+      </p:sp>
+      <p:sp>
+        <p:nvSpPr>
+          <p:cNvPr id="10" name="Rounded Rectangle 9"/>
+          <p:cNvSpPr/>
+          <p:nvPr/>
+        </p:nvSpPr>
+        <p:spPr>
+          <a:xfrm>
+            <a:off x="3720510" y="3696004"/>
+            <a:ext cx="3138220" cy="399409"/>
+          </a:xfrm>
+          <a:prstGeom prst="roundRect">
+            <a:avLst/>
+          </a:prstGeom>
+          <a:solidFill>
+            <a:srgbClr val="1B3540"/>
+          </a:solidFill>
+          <a:ln>
+            <a:noFill/>
+          </a:ln>
+          <a:effectLst/>
+        </p:spPr>
+        <p:style>
+          <a:lnRef idx="1">
+            <a:schemeClr val="accent1"/>
+          </a:lnRef>
+          <a:fillRef idx="3">
+            <a:schemeClr val="accent1"/>
+          </a:fillRef>
+          <a:effectRef idx="2">
+            <a:schemeClr val="accent1"/>
+          </a:effectRef>
+          <a:fontRef idx="minor">
+            <a:schemeClr val="lt1"/>
+          </a:fontRef>
+        </p:style>
+        <p:txBody>
+          <a:bodyPr rtlCol="0" anchor="ctr"/>
+          <a:lstStyle/>
+          <a:p>
+            <a:pPr algn="ctr"/>
+          </a:p>
+        </p:txBody>
+      </p:sp>
+      <p:sp>
+        <p:nvSpPr>
+          <p:cNvPr id="11" name="Rounded Rectangle 10"/>
+          <p:cNvSpPr/>
+          <p:nvPr/>
+        </p:nvSpPr>
+        <p:spPr>
+          <a:xfrm>
+            <a:off x="3701491" y="4856195"/>
+            <a:ext cx="3899001" cy="323331"/>
+          </a:xfrm>
+          <a:prstGeom prst="roundRect">
+            <a:avLst/>
+          </a:prstGeom>
+          <a:solidFill>
+            <a:srgbClr val="16303A"/>
+          </a:solidFill>
+          <a:ln>
+            <a:noFill/>
+          </a:ln>
+          <a:effectLst/>
+        </p:spPr>
+        <p:style>
+          <a:lnRef idx="1">
+            <a:schemeClr val="accent1"/>
+          </a:lnRef>
+          <a:fillRef idx="3">
+            <a:schemeClr val="accent1"/>
+          </a:fillRef>
+          <a:effectRef idx="2">
+            <a:schemeClr val="accent1"/>
+          </a:effectRef>
+          <a:fontRef idx="minor">
+            <a:schemeClr val="lt1"/>
+          </a:fontRef>
+        </p:style>
+        <p:txBody>
+          <a:bodyPr rtlCol="0" anchor="ctr"/>
+          <a:lstStyle/>
+          <a:p>
+            <a:pPr algn="ctr"/>
+          </a:p>
+        </p:txBody>
+      </p:sp>
+      <p:sp>
+        <p:nvSpPr>
+          <p:cNvPr id="12" name="Rounded Rectangle 11"/>
+          <p:cNvSpPr/>
+          <p:nvPr/>
+        </p:nvSpPr>
+        <p:spPr>
+          <a:xfrm>
+            <a:off x="7695590" y="4856195"/>
+            <a:ext cx="779800" cy="323331"/>
+          </a:xfrm>
+          <a:prstGeom prst="roundRect">
+            <a:avLst/>
+          </a:prstGeom>
+          <a:solidFill>
+            <a:srgbClr val="01AEFD"/>
+          </a:solidFill>
+          <a:ln>
+            <a:noFill/>
+          </a:ln>
+          <a:effectLst/>
+        </p:spPr>
+        <p:style>
+          <a:lnRef idx="1">
+            <a:schemeClr val="accent1"/>
+          </a:lnRef>
+          <a:fillRef idx="3">
+            <a:schemeClr val="accent1"/>
+          </a:fillRef>
+          <a:effectRef idx="2">
+            <a:schemeClr val="accent1"/>
+          </a:effectRef>
+          <a:fontRef idx="minor">
+            <a:schemeClr val="lt1"/>
+          </a:fontRef>
+        </p:style>
+        <p:txBody>
+          <a:bodyPr rtlCol="0" anchor="ctr"/>
+          <a:lstStyle/>
+          <a:p>
+            <a:pPr algn="ctr"/>
+          </a:p>
+        </p:txBody>
+      </p:sp>
+      <p:sp>
+        <p:nvSpPr>
+          <p:cNvPr id="13" name="Rounded Rectangle 12"/>
+          <p:cNvSpPr/>
+          <p:nvPr/>
+        </p:nvSpPr>
+        <p:spPr>
+          <a:xfrm>
+            <a:off x="3720510" y="5407761"/>
+            <a:ext cx="1616659" cy="95097"/>
+          </a:xfrm>
+          <a:prstGeom prst="roundRect">
+            <a:avLst/>
+          </a:prstGeom>
+          <a:solidFill>
+            <a:srgbClr val="2A4550"/>
+          </a:solidFill>
+          <a:ln>
+            <a:noFill/>
+          </a:ln>
+          <a:effectLst/>
+        </p:spPr>
+        <p:style>
+          <a:lnRef idx="1">
+            <a:schemeClr val="accent1"/>
+          </a:lnRef>
+          <a:fillRef idx="3">
+            <a:schemeClr val="accent1"/>
+          </a:fillRef>
+          <a:effectRef idx="2">
+            <a:schemeClr val="accent1"/>
+          </a:effectRef>
+          <a:fontRef idx="minor">
+            <a:schemeClr val="lt1"/>
+          </a:fontRef>
+        </p:style>
+        <p:txBody>
+          <a:bodyPr rtlCol="0" anchor="ctr"/>
+          <a:lstStyle/>
+          <a:p>
+            <a:pPr algn="ctr"/>
+          </a:p>
+        </p:txBody>
+      </p:sp>
+      <p:sp>
+        <p:nvSpPr>
+          <p:cNvPr id="14" name="Rounded Rectangle 13"/>
+          <p:cNvSpPr/>
+          <p:nvPr/>
+        </p:nvSpPr>
+        <p:spPr>
+          <a:xfrm>
+            <a:off x="3682471" y="2630911"/>
+            <a:ext cx="2929006" cy="475488"/>
+          </a:xfrm>
+          <a:prstGeom prst="roundRect">
+            <a:avLst/>
+          </a:prstGeom>
+          <a:noFill/>
+          <a:ln w="44450">
+            <a:solidFill>
+              <a:srgbClr val="FFD633"/>
+            </a:solidFill>
+          </a:ln>
+          <a:effectLst/>
+        </p:spPr>
+        <p:style>
+          <a:lnRef idx="1">
+            <a:schemeClr val="accent1"/>
+          </a:lnRef>
+          <a:fillRef idx="3">
+            <a:schemeClr val="accent1"/>
+          </a:fillRef>
+          <a:effectRef idx="2">
+            <a:schemeClr val="accent1"/>
+          </a:effectRef>
+          <a:fontRef idx="minor">
+            <a:schemeClr val="lt1"/>
+          </a:fontRef>
+        </p:style>
+        <p:txBody>
+          <a:bodyPr rtlCol="0" anchor="ctr"/>
+          <a:lstStyle/>
+          <a:p>
+            <a:pPr algn="ctr"/>
+          </a:p>
+        </p:txBody>
+      </p:sp>
+      <p:sp>
+        <p:nvSpPr>
+          <p:cNvPr id="15" name="TextBox 14"/>
+          <p:cNvSpPr txBox="1"/>
+          <p:nvPr/>
+        </p:nvSpPr>
+        <p:spPr>
+          <a:xfrm>
+            <a:off x="822960" y="6172200"/>
+            <a:ext cx="10515600" cy="548640"/>
+          </a:xfrm>
+          <a:prstGeom prst="rect">
+            <a:avLst/>
+          </a:prstGeom>
+          <a:noFill/>
+        </p:spPr>
+        <p:txBody>
+          <a:bodyPr wrap="square">
+            <a:spAutoFit/>
+          </a:bodyPr>
+          <a:lstStyle/>
+          <a:p>
+            <a:r>
+              <a:rPr sz="2000">
+                <a:solidFill>
+                  <a:srgbClr val="0A6299"/>
+                </a:solidFill>
+              </a:rPr>
+              <a:t>line-height spaces the lines inside a message.</a:t>
+            </a:r>
+          </a:p>
+        </p:txBody>
+      </p:sp>
+    </p:spTree>
+  </p:cSld>
+  <p:clrMapOvr>
+    <a:masterClrMapping/>
+  </p:clrMapOvr>
+</p:sld>
+</file>
+
+<file path=ppt/slides/slide44.xml><?xml version="1.0" encoding="utf-8"?>
+<p:sld xmlns:a="http://schemas.openxmlformats.org/drawingml/2006/main" xmlns:p="http://schemas.openxmlformats.org/presentationml/2006/main" xmlns:r="http://schemas.openxmlformats.org/officeDocument/2006/relationships">
+  <p:cSld>
+    <p:bg>
+      <p:bgPr>
+        <a:solidFill>
           <a:srgbClr val="102127"/>
         </a:solidFill>
         <a:effectLst/>
@@ -16537,7 +17147,7 @@
 </p:sld>
 </file>
 
-<file path=ppt/slides/slide44.xml><?xml version="1.0" encoding="utf-8"?>
+<file path=ppt/slides/slide45.xml><?xml version="1.0" encoding="utf-8"?>
 <p:sld xmlns:a="http://schemas.openxmlformats.org/drawingml/2006/main" xmlns:p="http://schemas.openxmlformats.org/presentationml/2006/main" xmlns:r="http://schemas.openxmlformats.org/officeDocument/2006/relationships">
   <p:cSld>
     <p:spTree>
@@ -16682,7 +17292,7 @@
 </p:sld>
 </file>
 
-<file path=ppt/slides/slide45.xml><?xml version="1.0" encoding="utf-8"?>
+<file path=ppt/slides/slide46.xml><?xml version="1.0" encoding="utf-8"?>
 <p:sld xmlns:a="http://schemas.openxmlformats.org/drawingml/2006/main" xmlns:p="http://schemas.openxmlformats.org/presentationml/2006/main" xmlns:r="http://schemas.openxmlformats.org/officeDocument/2006/relationships">
   <p:cSld>
     <p:spTree>

</xml_diff>